<commit_message>
Product Variant - working with edit feature
</commit_message>
<xml_diff>
--- a/.lessons/59 Vendor Product And Related Features/11 Product Variant - show created data in datatable/1.pptx
+++ b/.lessons/59 Vendor Product And Related Features/11 Product Variant - show created data in datatable/1.pptx
@@ -12,7 +12,9 @@
     <p:sldId id="414" r:id="rId6"/>
     <p:sldId id="419" r:id="rId7"/>
     <p:sldId id="420" r:id="rId8"/>
-    <p:sldId id="415" r:id="rId9"/>
+    <p:sldId id="421" r:id="rId9"/>
+    <p:sldId id="422" r:id="rId10"/>
+    <p:sldId id="415" r:id="rId11"/>
   </p:sldIdLst>
   <p:sldSz cx="12192000" cy="6858000"/>
   <p:notesSz cx="6858000" cy="9144000"/>
@@ -3391,10 +3393,10 @@
       </p:sp>
       <p:pic>
         <p:nvPicPr>
-          <p:cNvPr id="6" name="Picture 5">
-            <a:extLst>
-              <a:ext uri="{FF2B5EF4-FFF2-40B4-BE49-F238E27FC236}">
-                <a16:creationId xmlns:a16="http://schemas.microsoft.com/office/drawing/2014/main" id="{B1BD6131-BB9E-2686-11F6-8C4C76B29E1F}"/>
+          <p:cNvPr id="4" name="Picture 3">
+            <a:extLst>
+              <a:ext uri="{FF2B5EF4-FFF2-40B4-BE49-F238E27FC236}">
+                <a16:creationId xmlns:a16="http://schemas.microsoft.com/office/drawing/2014/main" id="{CA514283-2477-DE89-6856-FEC70484104E}"/>
               </a:ext>
             </a:extLst>
           </p:cNvPr>
@@ -3411,8 +3413,8 @@
         </p:blipFill>
         <p:spPr>
           <a:xfrm>
-            <a:off x="0" y="593500"/>
-            <a:ext cx="12192000" cy="5671000"/>
+            <a:off x="0" y="633777"/>
+            <a:ext cx="12192000" cy="5590446"/>
           </a:xfrm>
           <a:prstGeom prst="rect">
             <a:avLst/>
@@ -3423,6 +3425,92 @@
     <p:extLst>
       <p:ext uri="{BB962C8B-B14F-4D97-AF65-F5344CB8AC3E}">
         <p14:creationId xmlns:p14="http://schemas.microsoft.com/office/powerpoint/2010/main" val="3863838039"/>
+      </p:ext>
+    </p:extLst>
+  </p:cSld>
+  <p:clrMapOvr>
+    <a:masterClrMapping/>
+  </p:clrMapOvr>
+</p:sld>
+</file>
+
+<file path=ppt/slides/slide10.xml><?xml version="1.0" encoding="utf-8"?>
+<p:sld xmlns:a="http://schemas.openxmlformats.org/drawingml/2006/main" xmlns:r="http://schemas.openxmlformats.org/officeDocument/2006/relationships" xmlns:p="http://schemas.openxmlformats.org/presentationml/2006/main">
+  <p:cSld>
+    <p:spTree>
+      <p:nvGrpSpPr>
+        <p:cNvPr id="1" name="">
+          <a:extLst>
+            <a:ext uri="{FF2B5EF4-FFF2-40B4-BE49-F238E27FC236}">
+              <a16:creationId xmlns:a16="http://schemas.microsoft.com/office/drawing/2014/main" id="{074AE5AA-517F-F260-892A-328B0CAF8207}"/>
+            </a:ext>
+          </a:extLst>
+        </p:cNvPr>
+        <p:cNvGrpSpPr/>
+        <p:nvPr/>
+      </p:nvGrpSpPr>
+      <p:grpSpPr>
+        <a:xfrm>
+          <a:off x="0" y="0"/>
+          <a:ext cx="0" cy="0"/>
+          <a:chOff x="0" y="0"/>
+          <a:chExt cx="0" cy="0"/>
+        </a:xfrm>
+      </p:grpSpPr>
+      <p:sp>
+        <p:nvSpPr>
+          <p:cNvPr id="3" name="TextBox 2">
+            <a:extLst>
+              <a:ext uri="{FF2B5EF4-FFF2-40B4-BE49-F238E27FC236}">
+                <a16:creationId xmlns:a16="http://schemas.microsoft.com/office/drawing/2014/main" id="{04478110-B690-C635-530D-DC4FBFAD36C1}"/>
+              </a:ext>
+            </a:extLst>
+          </p:cNvPr>
+          <p:cNvSpPr txBox="1"/>
+          <p:nvPr/>
+        </p:nvSpPr>
+        <p:spPr>
+          <a:xfrm>
+            <a:off x="0" y="0"/>
+            <a:ext cx="12192000" cy="355354"/>
+          </a:xfrm>
+          <a:prstGeom prst="rect">
+            <a:avLst/>
+          </a:prstGeom>
+          <a:noFill/>
+        </p:spPr>
+        <p:txBody>
+          <a:bodyPr wrap="square">
+            <a:spAutoFit/>
+          </a:bodyPr>
+          <a:lstStyle/>
+          <a:p>
+            <a:pPr>
+              <a:lnSpc>
+                <a:spcPct val="150000"/>
+              </a:lnSpc>
+              <a:buNone/>
+            </a:pPr>
+            <a:r>
+              <a:rPr kumimoji="0" lang="en-US" altLang="en-US" sz="1300" b="0" i="0" u="none" strike="noStrike" cap="none" normalizeH="0" baseline="0">
+                <a:ln>
+                  <a:noFill/>
+                </a:ln>
+                <a:solidFill>
+                  <a:schemeClr val="tx1"/>
+                </a:solidFill>
+                <a:effectLst/>
+                <a:latin typeface="Arial" panose="020B0604020202020204" pitchFamily="34" charset="0"/>
+              </a:rPr>
+              <a:t>.</a:t>
+            </a:r>
+          </a:p>
+        </p:txBody>
+      </p:sp>
+    </p:spTree>
+    <p:extLst>
+      <p:ext uri="{BB962C8B-B14F-4D97-AF65-F5344CB8AC3E}">
+        <p14:creationId xmlns:p14="http://schemas.microsoft.com/office/powerpoint/2010/main" val="3737127349"/>
       </p:ext>
     </p:extLst>
   </p:cSld>
@@ -3507,10 +3595,10 @@
       </p:sp>
       <p:pic>
         <p:nvPicPr>
-          <p:cNvPr id="4" name="Picture 3">
-            <a:extLst>
-              <a:ext uri="{FF2B5EF4-FFF2-40B4-BE49-F238E27FC236}">
-                <a16:creationId xmlns:a16="http://schemas.microsoft.com/office/drawing/2014/main" id="{CB2A92D5-7018-1509-BDB5-F4539A02CB72}"/>
+          <p:cNvPr id="5" name="Picture 4">
+            <a:extLst>
+              <a:ext uri="{FF2B5EF4-FFF2-40B4-BE49-F238E27FC236}">
+                <a16:creationId xmlns:a16="http://schemas.microsoft.com/office/drawing/2014/main" id="{955E4DE7-C1B8-2794-90D9-911E9558552A}"/>
               </a:ext>
             </a:extLst>
           </p:cNvPr>
@@ -3527,8 +3615,8 @@
         </p:blipFill>
         <p:spPr>
           <a:xfrm>
-            <a:off x="543617" y="0"/>
-            <a:ext cx="11104765" cy="6858000"/>
+            <a:off x="474689" y="0"/>
+            <a:ext cx="11242622" cy="6858000"/>
           </a:xfrm>
           <a:prstGeom prst="rect">
             <a:avLst/>
@@ -3623,10 +3711,10 @@
       </p:sp>
       <p:pic>
         <p:nvPicPr>
-          <p:cNvPr id="4" name="Picture 3">
-            <a:extLst>
-              <a:ext uri="{FF2B5EF4-FFF2-40B4-BE49-F238E27FC236}">
-                <a16:creationId xmlns:a16="http://schemas.microsoft.com/office/drawing/2014/main" id="{1B090EB1-85B0-396C-EC19-DB5197CEBB50}"/>
+          <p:cNvPr id="5" name="Picture 4">
+            <a:extLst>
+              <a:ext uri="{FF2B5EF4-FFF2-40B4-BE49-F238E27FC236}">
+                <a16:creationId xmlns:a16="http://schemas.microsoft.com/office/drawing/2014/main" id="{B97DBBAD-2BC4-03EE-946D-A70454931306}"/>
               </a:ext>
             </a:extLst>
           </p:cNvPr>
@@ -3643,8 +3731,8 @@
         </p:blipFill>
         <p:spPr>
           <a:xfrm>
-            <a:off x="2353672" y="0"/>
-            <a:ext cx="7484655" cy="6858000"/>
+            <a:off x="1781829" y="0"/>
+            <a:ext cx="8628341" cy="6858000"/>
           </a:xfrm>
           <a:prstGeom prst="rect">
             <a:avLst/>
@@ -3739,10 +3827,10 @@
       </p:sp>
       <p:pic>
         <p:nvPicPr>
-          <p:cNvPr id="4" name="Picture 3">
-            <a:extLst>
-              <a:ext uri="{FF2B5EF4-FFF2-40B4-BE49-F238E27FC236}">
-                <a16:creationId xmlns:a16="http://schemas.microsoft.com/office/drawing/2014/main" id="{29A77B27-FFF6-BA73-5DB2-C9DE3A8F260D}"/>
+          <p:cNvPr id="5" name="Picture 4">
+            <a:extLst>
+              <a:ext uri="{FF2B5EF4-FFF2-40B4-BE49-F238E27FC236}">
+                <a16:creationId xmlns:a16="http://schemas.microsoft.com/office/drawing/2014/main" id="{C33DAE90-E98F-15EB-450C-56C8B93FBE8D}"/>
               </a:ext>
             </a:extLst>
           </p:cNvPr>
@@ -3759,8 +3847,8 @@
         </p:blipFill>
         <p:spPr>
           <a:xfrm>
-            <a:off x="2497841" y="0"/>
-            <a:ext cx="7196318" cy="6858000"/>
+            <a:off x="2444978" y="0"/>
+            <a:ext cx="7302043" cy="6858000"/>
           </a:xfrm>
           <a:prstGeom prst="rect">
             <a:avLst/>
@@ -3853,6 +3941,36 @@
           </a:p>
         </p:txBody>
       </p:sp>
+      <p:pic>
+        <p:nvPicPr>
+          <p:cNvPr id="6" name="Picture 5">
+            <a:extLst>
+              <a:ext uri="{FF2B5EF4-FFF2-40B4-BE49-F238E27FC236}">
+                <a16:creationId xmlns:a16="http://schemas.microsoft.com/office/drawing/2014/main" id="{C0CF546E-7F72-672F-2A0C-729488061910}"/>
+              </a:ext>
+            </a:extLst>
+          </p:cNvPr>
+          <p:cNvPicPr>
+            <a:picLocks noChangeAspect="1"/>
+          </p:cNvPicPr>
+          <p:nvPr/>
+        </p:nvPicPr>
+        <p:blipFill>
+          <a:blip r:embed="rId2"/>
+          <a:stretch>
+            <a:fillRect/>
+          </a:stretch>
+        </p:blipFill>
+        <p:spPr>
+          <a:xfrm>
+            <a:off x="2582852" y="0"/>
+            <a:ext cx="7026295" cy="6858000"/>
+          </a:xfrm>
+          <a:prstGeom prst="rect">
+            <a:avLst/>
+          </a:prstGeom>
+        </p:spPr>
+      </p:pic>
     </p:spTree>
     <p:extLst>
       <p:ext uri="{BB962C8B-B14F-4D97-AF65-F5344CB8AC3E}">
@@ -3924,21 +4042,60 @@
               <a:buNone/>
             </a:pPr>
             <a:r>
-              <a:rPr kumimoji="0" lang="en-US" altLang="en-US" sz="1300" b="0" i="0" u="none" strike="noStrike" cap="none" normalizeH="0" baseline="0">
-                <a:ln>
-                  <a:noFill/>
-                </a:ln>
-                <a:solidFill>
-                  <a:schemeClr val="tx1"/>
-                </a:solidFill>
-                <a:effectLst/>
+              <a:rPr lang="en-US" altLang="en-US" sz="1300">
                 <a:latin typeface="Arial" panose="020B0604020202020204" pitchFamily="34" charset="0"/>
               </a:rPr>
-              <a:t>.</a:t>
-            </a:r>
-          </a:p>
-        </p:txBody>
-      </p:sp>
+              <a:t>Create Variant </a:t>
+            </a:r>
+            <a:r>
+              <a:rPr lang="az-Latn-AZ" altLang="en-US" sz="1300">
+                <a:latin typeface="Arial" panose="020B0604020202020204" pitchFamily="34" charset="0"/>
+              </a:rPr>
+              <a:t>düyməsini klikləyərək variantlar əlavə etdikdən sonrakı nəticə.</a:t>
+            </a:r>
+            <a:endParaRPr kumimoji="0" lang="en-US" altLang="en-US" sz="1300" b="0" i="0" u="none" strike="noStrike" cap="none" normalizeH="0" baseline="0">
+              <a:ln>
+                <a:noFill/>
+              </a:ln>
+              <a:solidFill>
+                <a:schemeClr val="tx1"/>
+              </a:solidFill>
+              <a:effectLst/>
+              <a:latin typeface="Arial" panose="020B0604020202020204" pitchFamily="34" charset="0"/>
+            </a:endParaRPr>
+          </a:p>
+        </p:txBody>
+      </p:sp>
+      <p:pic>
+        <p:nvPicPr>
+          <p:cNvPr id="4" name="Picture 3">
+            <a:extLst>
+              <a:ext uri="{FF2B5EF4-FFF2-40B4-BE49-F238E27FC236}">
+                <a16:creationId xmlns:a16="http://schemas.microsoft.com/office/drawing/2014/main" id="{A73D5040-D8FA-2659-9512-45BCDD73515E}"/>
+              </a:ext>
+            </a:extLst>
+          </p:cNvPr>
+          <p:cNvPicPr>
+            <a:picLocks noChangeAspect="1"/>
+          </p:cNvPicPr>
+          <p:nvPr/>
+        </p:nvPicPr>
+        <p:blipFill>
+          <a:blip r:embed="rId2"/>
+          <a:stretch>
+            <a:fillRect/>
+          </a:stretch>
+        </p:blipFill>
+        <p:spPr>
+          <a:xfrm>
+            <a:off x="0" y="1219797"/>
+            <a:ext cx="12192000" cy="4418406"/>
+          </a:xfrm>
+          <a:prstGeom prst="rect">
+            <a:avLst/>
+          </a:prstGeom>
+        </p:spPr>
+      </p:pic>
     </p:spTree>
     <p:extLst>
       <p:ext uri="{BB962C8B-B14F-4D97-AF65-F5344CB8AC3E}">
@@ -4025,6 +4182,36 @@
           </a:p>
         </p:txBody>
       </p:sp>
+      <p:pic>
+        <p:nvPicPr>
+          <p:cNvPr id="4" name="Picture 3">
+            <a:extLst>
+              <a:ext uri="{FF2B5EF4-FFF2-40B4-BE49-F238E27FC236}">
+                <a16:creationId xmlns:a16="http://schemas.microsoft.com/office/drawing/2014/main" id="{D498750C-1727-9C00-DCFC-57FCBF637307}"/>
+              </a:ext>
+            </a:extLst>
+          </p:cNvPr>
+          <p:cNvPicPr>
+            <a:picLocks noChangeAspect="1"/>
+          </p:cNvPicPr>
+          <p:nvPr/>
+        </p:nvPicPr>
+        <p:blipFill>
+          <a:blip r:embed="rId2"/>
+          <a:stretch>
+            <a:fillRect/>
+          </a:stretch>
+        </p:blipFill>
+        <p:spPr>
+          <a:xfrm>
+            <a:off x="3389264" y="0"/>
+            <a:ext cx="5413472" cy="6858000"/>
+          </a:xfrm>
+          <a:prstGeom prst="rect">
+            <a:avLst/>
+          </a:prstGeom>
+        </p:spPr>
+      </p:pic>
     </p:spTree>
     <p:extLst>
       <p:ext uri="{BB962C8B-B14F-4D97-AF65-F5344CB8AC3E}">
@@ -4046,7 +4233,7 @@
         <p:cNvPr id="1" name="">
           <a:extLst>
             <a:ext uri="{FF2B5EF4-FFF2-40B4-BE49-F238E27FC236}">
-              <a16:creationId xmlns:a16="http://schemas.microsoft.com/office/drawing/2014/main" id="{074AE5AA-517F-F260-892A-328B0CAF8207}"/>
+              <a16:creationId xmlns:a16="http://schemas.microsoft.com/office/drawing/2014/main" id="{3518F25F-7245-39C7-2563-5EF3FB05E442}"/>
             </a:ext>
           </a:extLst>
         </p:cNvPr>
@@ -4066,7 +4253,7 @@
           <p:cNvPr id="3" name="TextBox 2">
             <a:extLst>
               <a:ext uri="{FF2B5EF4-FFF2-40B4-BE49-F238E27FC236}">
-                <a16:creationId xmlns:a16="http://schemas.microsoft.com/office/drawing/2014/main" id="{04478110-B690-C635-530D-DC4FBFAD36C1}"/>
+                <a16:creationId xmlns:a16="http://schemas.microsoft.com/office/drawing/2014/main" id="{0FEFA4BC-30BF-1248-9E0D-940CC5767E6C}"/>
               </a:ext>
             </a:extLst>
           </p:cNvPr>
@@ -4111,10 +4298,126 @@
           </a:p>
         </p:txBody>
       </p:sp>
+      <p:pic>
+        <p:nvPicPr>
+          <p:cNvPr id="4" name="Picture 3">
+            <a:extLst>
+              <a:ext uri="{FF2B5EF4-FFF2-40B4-BE49-F238E27FC236}">
+                <a16:creationId xmlns:a16="http://schemas.microsoft.com/office/drawing/2014/main" id="{D22E19F7-7CA5-2680-B3B3-DFB4DB044A7C}"/>
+              </a:ext>
+            </a:extLst>
+          </p:cNvPr>
+          <p:cNvPicPr>
+            <a:picLocks noChangeAspect="1"/>
+          </p:cNvPicPr>
+          <p:nvPr/>
+        </p:nvPicPr>
+        <p:blipFill>
+          <a:blip r:embed="rId2"/>
+          <a:stretch>
+            <a:fillRect/>
+          </a:stretch>
+        </p:blipFill>
+        <p:spPr>
+          <a:xfrm>
+            <a:off x="0" y="1250492"/>
+            <a:ext cx="12192000" cy="4357015"/>
+          </a:xfrm>
+          <a:prstGeom prst="rect">
+            <a:avLst/>
+          </a:prstGeom>
+        </p:spPr>
+      </p:pic>
     </p:spTree>
     <p:extLst>
       <p:ext uri="{BB962C8B-B14F-4D97-AF65-F5344CB8AC3E}">
-        <p14:creationId xmlns:p14="http://schemas.microsoft.com/office/powerpoint/2010/main" val="3737127349"/>
+        <p14:creationId xmlns:p14="http://schemas.microsoft.com/office/powerpoint/2010/main" val="1884040368"/>
+      </p:ext>
+    </p:extLst>
+  </p:cSld>
+  <p:clrMapOvr>
+    <a:masterClrMapping/>
+  </p:clrMapOvr>
+</p:sld>
+</file>
+
+<file path=ppt/slides/slide9.xml><?xml version="1.0" encoding="utf-8"?>
+<p:sld xmlns:a="http://schemas.openxmlformats.org/drawingml/2006/main" xmlns:r="http://schemas.openxmlformats.org/officeDocument/2006/relationships" xmlns:p="http://schemas.openxmlformats.org/presentationml/2006/main">
+  <p:cSld>
+    <p:spTree>
+      <p:nvGrpSpPr>
+        <p:cNvPr id="1" name="">
+          <a:extLst>
+            <a:ext uri="{FF2B5EF4-FFF2-40B4-BE49-F238E27FC236}">
+              <a16:creationId xmlns:a16="http://schemas.microsoft.com/office/drawing/2014/main" id="{87337595-7EC5-9987-1033-3C16D6A4B107}"/>
+            </a:ext>
+          </a:extLst>
+        </p:cNvPr>
+        <p:cNvGrpSpPr/>
+        <p:nvPr/>
+      </p:nvGrpSpPr>
+      <p:grpSpPr>
+        <a:xfrm>
+          <a:off x="0" y="0"/>
+          <a:ext cx="0" cy="0"/>
+          <a:chOff x="0" y="0"/>
+          <a:chExt cx="0" cy="0"/>
+        </a:xfrm>
+      </p:grpSpPr>
+      <p:sp>
+        <p:nvSpPr>
+          <p:cNvPr id="3" name="TextBox 2">
+            <a:extLst>
+              <a:ext uri="{FF2B5EF4-FFF2-40B4-BE49-F238E27FC236}">
+                <a16:creationId xmlns:a16="http://schemas.microsoft.com/office/drawing/2014/main" id="{616A9139-C233-434A-E1CC-9D8ACA30068B}"/>
+              </a:ext>
+            </a:extLst>
+          </p:cNvPr>
+          <p:cNvSpPr txBox="1"/>
+          <p:nvPr/>
+        </p:nvSpPr>
+        <p:spPr>
+          <a:xfrm>
+            <a:off x="0" y="0"/>
+            <a:ext cx="12192000" cy="355354"/>
+          </a:xfrm>
+          <a:prstGeom prst="rect">
+            <a:avLst/>
+          </a:prstGeom>
+          <a:noFill/>
+        </p:spPr>
+        <p:txBody>
+          <a:bodyPr wrap="square">
+            <a:spAutoFit/>
+          </a:bodyPr>
+          <a:lstStyle/>
+          <a:p>
+            <a:pPr>
+              <a:lnSpc>
+                <a:spcPct val="150000"/>
+              </a:lnSpc>
+              <a:buNone/>
+            </a:pPr>
+            <a:r>
+              <a:rPr kumimoji="0" lang="en-US" altLang="en-US" sz="1300" b="0" i="0" u="none" strike="noStrike" cap="none" normalizeH="0" baseline="0">
+                <a:ln>
+                  <a:noFill/>
+                </a:ln>
+                <a:solidFill>
+                  <a:schemeClr val="tx1"/>
+                </a:solidFill>
+                <a:effectLst/>
+                <a:latin typeface="Arial" panose="020B0604020202020204" pitchFamily="34" charset="0"/>
+              </a:rPr>
+              <a:t>.</a:t>
+            </a:r>
+          </a:p>
+        </p:txBody>
+      </p:sp>
+    </p:spTree>
+    <p:extLst>
+      <p:ext uri="{BB962C8B-B14F-4D97-AF65-F5344CB8AC3E}">
+        <p14:creationId xmlns:p14="http://schemas.microsoft.com/office/powerpoint/2010/main" val="2355322881"/>
       </p:ext>
     </p:extLst>
   </p:cSld>

</xml_diff>